<commit_message>
docs: dong bo slide PowerPoint Buoi 8 va tai lieu huong dan thuc hanh 6 buoc
</commit_message>
<xml_diff>
--- a/NGINX_Buoi_8_Nhom_7.pptx
+++ b/NGINX_Buoi_8_Nhom_7.pptx
@@ -649,7 +649,7 @@
           </a:p>
           <a:p>
             <a:r>
-              <a:t>Bước 2 trong Section 3 PDF: Reverse Proxy ghép cặp Frontend và 1 Backend API. Lưu ý quan trọng: API dùng trong bài là tính năng dữ liệu nghiệp vụ thật '/api/products' (Node.js cổng 3000), không phải mock đơn giản. Giải thích kỹ: Same-Origin giúp tránh lỗi CORS cho luồng gọi nội bộ giữa FE và BE, nhưng nếu có ứng dụng bên ngoài gọi vào thì vẫn phải áp dụng chính sách CORS. Quy tắc dấu slash: Nếu viết proxy_pass http://backend_cluster/ (có slash cuối), NGINX sẽ cắt bỏ /api/ và chỉ gửi /products tới backend.</a:t>
+              <a:t>Bước 2 trong Section 3 PDF: Reverse Proxy ghép cặp Frontend và 1 Backend API. Lưu ý quan trọng: Ứng dụng Quản lý Sản phẩm Mini cung cấp CRUD thật lưu trong CSDL PostgreSQL (db:5432) qua kiến trúc Controller - Service - Repository. Giải thích kỹ: Same-Origin giúp tránh lỗi CORS cho luồng gọi nội bộ giữa FE và BE, nhưng nếu có ứng dụng bên ngoài gọi vào thì vẫn phải áp dụng chính sách CORS. Quy tắc dấu slash: Nếu viết proxy_pass http://backend_cluster/ (có slash cuối), NGINX sẽ cắt bỏ /api/ và chỉ gửi /products tới backend.</a:t>
             </a:r>
           </a:p>
           <a:p>
@@ -663,7 +663,7 @@
           </a:p>
           <a:p>
             <a:r>
-              <a:t>Thao tác demo: Bấm nút load sản phẩm trên giao diện, mở Network tab xem status 200 tại /api/products cùng origin.</a:t>
+              <a:t>Thao tác demo: Mở giao diện web, xem danh sách sản phẩm từ DB, thêm thử sản phẩm mới và mở F12 Network tab xem status 200/201 tại cùng origin.</a:t>
             </a:r>
           </a:p>
           <a:p>
@@ -889,7 +889,7 @@
           </a:p>
           <a:p>
             <a:r>
-              <a:t>Thao tác demo: Bấm nút 'Gửi liên tiếp 10 request' trên giao diện web, quan sát bộ đếm backend-1 và backend-2 tăng đều.</a:t>
+              <a:t>Thao tác demo: Bấm nút 'Gửi liên tiếp 10 request' trên giao diện web, quan sát bộ đếm api1 và api2 tăng đều.</a:t>
             </a:r>
           </a:p>
           <a:p>
@@ -1002,7 +1002,7 @@
           </a:p>
           <a:p>
             <a:r>
-              <a:t>Thao tác demo: Vào container NGINX chạy 'nslookup backend1' để chứng minh Docker DNS phân giải IP 172.x.x.x.</a:t>
+              <a:t>Thao tác demo: Vào container NGINX chạy 'nslookup api1' để chứng minh Docker DNS phân giải IP 172.x.x.x.</a:t>
             </a:r>
           </a:p>
           <a:p>
@@ -1779,7 +1779,7 @@
           </a:p>
           <a:p>
             <a:r>
-              <a:t>Nhấn mạnh rõ: Buổi 7 của Nhóm 6 đã phác thảo mô hình Docker Compose với Node.js cổng 3000 và NGINX ở mức sơ đồ. Chúng ta coi đó là tài liệu tham chiếu lý thuyết. Trong Buổi 8 này, Nhóm 7 xây dựng một bộ demo độc lập, viết cấu hình thực tế cho NGINX và kiểm chứng từng bước bằng mã nguồn chạy được trong thư mục demo/.</a:t>
+              <a:t>Nhấn mạnh rõ: Buổi 7 của Nhóm 6 đã phác thảo mô hình Docker Compose với Node.js cổng 3000 và NGINX ở mức sơ đồ. Chúng ta coi đó là tài liệu tham chiếu lý thuyết. Trong Buổi 8 này, Nhóm 7 xây dựng một dự án hoàn chỉnh chạy thật: 'Quản lý sản phẩm mini' với PostgreSQL và shared volume ảnh, viết cấu hình thực tế cho NGINX và kiểm chứng từng bước bằng mã nguồn chạy được trong thư mục demo/.</a:t>
             </a:r>
           </a:p>
           <a:p>
@@ -2118,7 +2118,7 @@
           </a:p>
           <a:p>
             <a:r>
-              <a:t>Nhấn mạnh với sinh viên: Cả 3 vai trò này đều có thể cấu hình đồng thời trên cùng một tiến trình NGINX duy nhất! Phân biệt Forward Proxy (đại diện cho client đi ra ngoài) và Reverse Proxy (đại diện cho server tiếp nhận client vào). Trong bài thực hành, NGINX đảm nhận cả 3: vừa là web server phục vụ file frontend tĩnh, vừa là reverse proxy cho /api/, vừa cân bằng tải upstream giữa backend1 và backend2.</a:t>
+              <a:t>Nhấn mạnh với sinh viên: Cả 3 vai trò này đều có thể cấu hình đồng thời trên cùng một tiến trình NGINX duy nhất! Phân biệt Forward Proxy (đại diện cho client đi ra ngoài) và Reverse Proxy (đại diện cho server tiếp nhận client vào). Trong bài thực hành, NGINX đảm nhận cả 3: vừa là web server phục vụ file frontend tĩnh, vừa là reverse proxy cho /api/, vừa cân bằng tải upstream giữa api1 và api2.</a:t>
             </a:r>
           </a:p>
           <a:p>
@@ -2344,7 +2344,7 @@
           </a:p>
           <a:p>
             <a:r>
-              <a:t>Slide này minh họa trực quan luồng đi của 1 request: 1. Client chỉ biết duy nhất 1 địa chỉ máy chủ: myapp.local:8080. 2. NGINX phân tích tiền tố URI: Nếu là / -&gt; Đọc file tĩnh trên đĩa trả về ngay. 3. Nếu là /api/... -&gt; NGINX ủy quyền (proxy_pass) sang cụm upstream backend1/backend2 ở cổng 3000.</a:t>
+              <a:t>Slide này minh họa trực quan luồng đi của 1 request: 1. Client chỉ biết duy nhất 1 địa chỉ máy chủ: myapp.local:8080. 2. NGINX phân tích tiền tố URI: Nếu là / -&gt; Đọc file tĩnh trên đĩa trả về ngay. 3. Nếu là /api/... -&gt; NGINX ủy quyền (proxy_pass) sang cụm upstream api1/api2 ở cổng 3000.</a:t>
             </a:r>
           </a:p>
           <a:p>
@@ -7172,7 +7172,7 @@
                 </a:solidFill>
                 <a:latin typeface="Segoe UI"/>
               </a:rPr>
-              <a:t>Từ giao diện frontend, bấm nút 'Tải danh sách sản phẩm' gọi API 'GET /api/products'. Đồng thời kiểm tra log trong container backend.</a:t>
+              <a:t>Frontend gọi API 'GET /api/products' và 'POST /api/products' qua NGINX. Backend đọc/ghi dữ liệu vào PostgreSQL thật và trả kết quả kèm instanceId.</a:t>
             </a:r>
           </a:p>
           <a:p>
@@ -7197,7 +7197,7 @@
                 </a:solidFill>
                 <a:latin typeface="Segoe UI"/>
               </a:rPr>
-              <a:t>Dữ liệu danh sách sản phẩm trả về dạng JSON hiển thị lên bảng giao diện; Console không có lỗi CORS; Backend ghi nhận request và log header.</a:t>
+              <a:t>Dữ liệu sản phẩm trả về JSON hiển thị trên giao diện; Thêm mới sản phẩm lưu thành công vào CSDL; Console không bị lỗi CORS; Log backend ghi nhận request.</a:t>
             </a:r>
           </a:p>
           <a:p>
@@ -7674,7 +7674,7 @@
             </a:r>
             <a:br/>
             <a:r>
-              <a:t>• Nếu thiếu: Backend nhận tên server nội bộ (vd: 'backend1:3000') khiến các đường link tuyệt đối do backend tự sinh bị sai lệch hoàn toàn.</a:t>
+              <a:t>• Nếu thiếu: Backend nhận tên server nội bộ (vd: 'api1:3000') khiến các đường link tuyệt đối do backend tự sinh bị sai lệch hoàn toàn.</a:t>
             </a:r>
           </a:p>
         </p:txBody>
@@ -8566,7 +8566,7 @@
               </a:defRPr>
             </a:pPr>
             <a:r>
-              <a:t>    server backend1:3000 max_fails=3 fail_timeout=10s;</a:t>
+              <a:t>    server api1:3000 max_fails=3 fail_timeout=10s;</a:t>
             </a:r>
           </a:p>
           <a:p>
@@ -8582,7 +8582,7 @@
               </a:defRPr>
             </a:pPr>
             <a:r>
-              <a:t>    server backend2:3000 max_fails=3 fail_timeout=10s;</a:t>
+              <a:t>    server api2:3000 max_fails=3 fail_timeout=10s;</a:t>
             </a:r>
           </a:p>
           <a:p>
@@ -8742,7 +8742,7 @@
                   <a:srgbClr val="0F172A"/>
                 </a:solidFill>
               </a:rPr>
-              <a:t>Mặc định phân phối tuần tự giữa backend1 và backend2. Trong thực tế, tỷ lệ có thể không chia đều 50/50 tuyệt đối do HTTP Keep-Alive hoặc browser prefetch.</a:t>
+              <a:t>Mặc định phân phối tuần tự giữa api1 và api2. Trong thực tế, tỷ lệ có thể không chia đều 50/50 tuyệt đối do HTTP Keep-Alive hoặc browser prefetch.</a:t>
             </a:r>
           </a:p>
           <a:p>
@@ -8937,7 +8937,7 @@
                 </a:solidFill>
                 <a:latin typeface="Segoe UI"/>
               </a:rPr>
-              <a:t>Khởi chạy song song 2 instance backend (backend1:3000, backend2:3000) trong compose.yaml. Gửi liên tiếp 10 request 'GET /api/products'.</a:t>
+              <a:t>Khởi chạy song song 2 instance backend (api1:3000, api2:3000) trong compose.yaml. Gửi liên tiếp 10 request 'GET /api/products'.</a:t>
             </a:r>
           </a:p>
           <a:p>
@@ -8962,7 +8962,7 @@
                 </a:solidFill>
                 <a:latin typeface="Segoe UI"/>
               </a:rPr>
-              <a:t>Dữ liệu phản hồi mang trường 'instanceId' luân phiên giữa backend-1 và backend-2, chứng minh tải được phân phối đều giữa 2 node.</a:t>
+              <a:t>Dữ liệu phản hồi mang trường 'instanceId' luân phiên giữa api1 và api2, chứng minh tải được phân phối đều giữa 2 node.</a:t>
             </a:r>
           </a:p>
           <a:p>
@@ -9472,7 +9472,7 @@
                   <a:srgbClr val="0F172A"/>
                 </a:solidFill>
               </a:rPr>
-              <a:t>  Mỗi service name ('backend1', 'backend2', 'proxy') tự động được phân giải thành địa chỉ IP nội bộ của container tương ứng.</a:t>
+              <a:t>  Mỗi service name ('api1', 'api2', 'db', 'proxy') tự động được phân giải thành địa chỉ IP nội bộ của container tương ứng.</a:t>
             </a:r>
           </a:p>
           <a:p>
@@ -9496,7 +9496,7 @@
                   <a:srgbClr val="0F172A"/>
                 </a:solidFill>
               </a:rPr>
-              <a:t>  NGINX chỉ cần cấu hình 'server backend1:3000;' mà không cần quan tâm IP nội bộ có thay đổi sau mỗi lần khởi động lại.</a:t>
+              <a:t>  NGINX chỉ cần cấu hình 'server api1:3000;' mà không cần quan tâm IP nội bộ có thay đổi sau mỗi lần khởi động lại.</a:t>
             </a:r>
           </a:p>
           <a:p>
@@ -10213,7 +10213,7 @@
               </a:defRPr>
             </a:pPr>
             <a:r>
-              <a:t>    server backend1:3000 max_fails=3 fail_timeout=10s;</a:t>
+              <a:t>    server api1:3000 max_fails=3 fail_timeout=10s;</a:t>
             </a:r>
           </a:p>
           <a:p>
@@ -10229,7 +10229,7 @@
               </a:defRPr>
             </a:pPr>
             <a:r>
-              <a:t>    server backend2:3000 max_fails=3 fail_timeout=10s;</a:t>
+              <a:t>    server api2:3000 max_fails=3 fail_timeout=10s;</a:t>
             </a:r>
           </a:p>
           <a:p>
@@ -15895,7 +15895,7 @@
                   <a:srgbClr val="16A34A"/>
                 </a:solidFill>
               </a:rPr>
-              <a:t>✔ Xây dựng Demo Độc lập: </a:t>
+              <a:t>✔ Ứng dụng Quản lý Sản phẩm Mini: </a:t>
             </a:r>
             <a:r>
               <a:rPr sz="1450">
@@ -15903,7 +15903,7 @@
                   <a:srgbClr val="0F172A"/>
                 </a:solidFill>
               </a:rPr>
-              <a:t>Tạo mới một ứng dụng demo gọn nhẹ: Frontend tĩnh, 2 backend Node.js (cổng 3000 trả instanceId), và NGINX Gateway (8080:80, 8443:443).</a:t>
+              <a:t>Xây dựng dự án chạy thật: Frontend tĩnh (SPA), 2 backend Node.js (api1 &amp; api2 cổng 3000), CSDL PostgreSQL (db:5432), shared volume uploads và NGINX Gateway (8080:80, 8443:443).</a:t>
             </a:r>
           </a:p>
           <a:p>
@@ -15926,7 +15926,7 @@
                   <a:srgbClr val="0F172A"/>
                 </a:solidFill>
               </a:rPr>
-              <a:t>Định tuyến đường dẫn '/ ' về frontend tĩnh và '/api/ ' về backend, loại bỏ rào cản CORS nội bộ qua Same-Origin.</a:t>
+              <a:t>Định tuyến đường dẫn '/' về frontend tĩnh và '/api/' về backend, loại bỏ rào cản CORS nội bộ qua Same-Origin.</a:t>
             </a:r>
           </a:p>
           <a:p>
@@ -16599,7 +16599,7 @@
                         </a:defRPr>
                       </a:pPr>
                       <a:r>
-                        <a:t>Request phân phối luân phiên Round-robin qua backend1 và backend2.</a:t>
+                        <a:t>Request phân phối luân phiên Round-robin qua api1 và api2.</a:t>
                       </a:r>
                     </a:p>
                   </a:txBody>
@@ -19999,11 +19999,11 @@
             </a:r>
             <a:br/>
             <a:r>
-              <a:t>backend1:3000 (Node.js)</a:t>
+              <a:t>api1:3000 (Node.js)</a:t>
             </a:r>
             <a:br/>
             <a:r>
-              <a:t>backend2:3000 (Node.js)</a:t>
+              <a:t>api2:3000 (Node.js)</a:t>
             </a:r>
             <a:br/>
             <a:r>

</xml_diff>

<commit_message>
docs: cập nhật tài liệu hướng dẫn và tái tạo bài thuyết trình Nhóm 8 HUCE
</commit_message>
<xml_diff>
--- a/NGINX_Buoi_8_Nhom_7.pptx
+++ b/NGINX_Buoi_8_Nhom_7.pptx
@@ -536,7 +536,7 @@
           </a:p>
           <a:p>
             <a:r>
-              <a:t>Chào mừng Thầy và các bạn đến với buổi báo cáo chuyên đề Buổi 8 của Nhóm 7. Chủ đề hôm nay tập trung vào: Cấu hình NGINX Reverse Proxy và Upstream nhiều backend. Nhóm 7 gồm 4 thành viên: Nguyễn Đức Mạnh, Nguyễn Tất Mạnh, Đỗ Công Trí, Nguyễn Huy Hoàng.</a:t>
+              <a:t>Chào mừng Thầy và các bạn đến với buổi báo cáo chuyên đề Buổi 8 của Nhóm 8. Chủ đề hôm nay tập trung vào: Cấu hình NGINX Reverse Proxy và Upstream nhiều backend. Nhóm 8 gồm 4 thành viên: Nguyễn Đức Mạnh, Nguyễn Tất Mạnh, Đỗ Công Trí, Nguyễn Huy Hoàng.</a:t>
             </a:r>
           </a:p>
           <a:p>
@@ -649,7 +649,7 @@
           </a:p>
           <a:p>
             <a:r>
-              <a:t>Bước 2 trong Section 3 PDF: Reverse Proxy ghép cặp Frontend và 1 Backend API. Lưu ý quan trọng: Ứng dụng Quản lý Sản phẩm Mini cung cấp CRUD thật lưu trong CSDL PostgreSQL (db:5432) qua kiến trúc Controller - Service - Repository. Giải thích kỹ: Same-Origin giúp tránh lỗi CORS cho luồng gọi nội bộ giữa FE và BE, nhưng nếu có ứng dụng bên ngoài gọi vào thì vẫn phải áp dụng chính sách CORS. Quy tắc dấu slash: Nếu viết proxy_pass http://backend_cluster/ (có slash cuối), NGINX sẽ cắt bỏ /api/ và chỉ gửi /products tới backend.</a:t>
+              <a:t>Bước 2 trong Section 3 PDF: Reverse Proxy ghép cặp Frontend và 1 Backend API. Lưu ý quan trọng: Ứng dụng HUCE Learning Store cung cấp dữ liệu sách và khóa học thật lưu trong CSDL PostgreSQL (db:5432) qua kiến trúc Controller - Service - Repository. Giải thích kỹ: Same-Origin giúp tránh lỗi CORS cho luồng gọi nội bộ giữa FE và BE, nhưng nếu có ứng dụng bên ngoài gọi vào thì vẫn phải áp dụng chính sách CORS. Quy tắc dấu slash: Nếu viết proxy_pass http://backend_cluster/ (có slash cuối), NGINX sẽ cắt bỏ /api/ và chỉ gửi /products tới backend.</a:t>
             </a:r>
           </a:p>
           <a:p>
@@ -663,7 +663,7 @@
           </a:p>
           <a:p>
             <a:r>
-              <a:t>Thao tác demo: Mở giao diện web, xem danh sách sản phẩm từ DB, thêm thử sản phẩm mới và mở F12 Network tab xem status 200/201 tại cùng origin.</a:t>
+              <a:t>Thao tác demo: Mở giao diện web, xem danh mục sách và khóa học từ DB, thêm vào giỏ và đặt hàng, mở F12 Network tab xem status 200/201 tại cùng origin.</a:t>
             </a:r>
           </a:p>
           <a:p>
@@ -1228,7 +1228,7 @@
           </a:p>
           <a:p>
             <a:r>
-              <a:t>Thao tác demo: Chọn payload 2 MB trên giao diện, bấm Upload nhận mã 413. Sau đó sửa default.conf thành 20m, chạy lệnh reload trong terminal và bấm lại nút Upload nhận mã 200 OK.</a:t>
+              <a:t>Thao tác demo: Chọn file ảnh mẫu 1.34 MB trên giao diện, bấm Upload nhận mã 413. Sau đó chuyển stage 5 (20m), reload và bấm lại nút Upload nhận mã 200 OK.</a:t>
             </a:r>
           </a:p>
           <a:p>
@@ -1779,7 +1779,7 @@
           </a:p>
           <a:p>
             <a:r>
-              <a:t>Nhấn mạnh rõ: Buổi 7 của Nhóm 6 đã phác thảo mô hình Docker Compose với Node.js cổng 3000 và NGINX ở mức sơ đồ. Chúng ta coi đó là tài liệu tham chiếu lý thuyết. Trong Buổi 8 này, Nhóm 7 xây dựng một dự án hoàn chỉnh chạy thật: 'Quản lý sản phẩm mini' với PostgreSQL và shared volume ảnh, viết cấu hình thực tế cho NGINX và kiểm chứng từng bước bằng mã nguồn chạy được trong thư mục demo/.</a:t>
+              <a:t>Nhấn mạnh rõ: Buổi 7 của Nhóm 6 đã phác thảo mô hình Docker Compose với Node.js cổng 3000 và NGINX ở mức sơ đồ. Chúng ta coi đó là tài liệu tham chiếu lý thuyết. Trong Buổi 8 này, Nhóm 8 xây dựng một dự án hoàn chỉnh chạy thật: 'HUCE Learning Store' (Cửa hàng học liệu &amp; khóa học công nghệ) với PostgreSQL và shared volume ảnh uploads_data, viết cấu hình thực tế cho NGINX và kiểm chứng từng bước bằng mã nguồn chạy được trong thư mục demo/.</a:t>
             </a:r>
           </a:p>
           <a:p>
@@ -5936,7 +5936,7 @@
               </a:defRPr>
             </a:pPr>
             <a:r>
-              <a:t>NHÓM 7</a:t>
+              <a:t>NHÓM 8</a:t>
             </a:r>
           </a:p>
         </p:txBody>
@@ -6518,7 +6518,7 @@
               </a:defRPr>
             </a:pPr>
             <a:r>
-              <a:t>Nhóm 7 • NGINX Reverse Proxy &amp; Upstream nhiều Backend</a:t>
+              <a:t>Nhóm 8 • NGINX Reverse Proxy &amp; Upstream nhiều Backend</a:t>
             </a:r>
           </a:p>
         </p:txBody>
@@ -7172,7 +7172,7 @@
                 </a:solidFill>
                 <a:latin typeface="Segoe UI"/>
               </a:rPr>
-              <a:t>Frontend gọi API 'GET /api/products' và 'POST /api/products' qua NGINX. Backend đọc/ghi dữ liệu vào PostgreSQL thật và trả kết quả kèm instanceId.</a:t>
+              <a:t>Frontend gọi API 'GET /api/products' (lấy danh mục sách/khóa học) và 'POST /api/orders' (đặt hàng) qua NGINX. Backend đọc/ghi dữ liệu vào PostgreSQL thật và trả kết quả kèm instanceId.</a:t>
             </a:r>
           </a:p>
           <a:p>
@@ -7197,7 +7197,7 @@
                 </a:solidFill>
                 <a:latin typeface="Segoe UI"/>
               </a:rPr>
-              <a:t>Dữ liệu sản phẩm trả về JSON hiển thị trên giao diện; Thêm mới sản phẩm lưu thành công vào CSDL; Console không bị lỗi CORS; Log backend ghi nhận request.</a:t>
+              <a:t>Dữ liệu học liệu trả về JSON hiển thị trên storefront; Đơn hàng lưu thành công vào CSDL; Console không bị lỗi CORS; Log backend ghi nhận request.</a:t>
             </a:r>
           </a:p>
           <a:p>
@@ -7466,7 +7466,7 @@
               </a:defRPr>
             </a:pPr>
             <a:r>
-              <a:t>Nhóm 7 • NGINX Reverse Proxy &amp; Upstream nhiều Backend</a:t>
+              <a:t>Nhóm 8 • NGINX Reverse Proxy &amp; Upstream nhiều Backend</a:t>
             </a:r>
           </a:p>
         </p:txBody>
@@ -8283,7 +8283,7 @@
               </a:defRPr>
             </a:pPr>
             <a:r>
-              <a:t>Nhóm 7 • NGINX Reverse Proxy &amp; Upstream nhiều Backend</a:t>
+              <a:t>Nhóm 8 • NGINX Reverse Proxy &amp; Upstream nhiều Backend</a:t>
             </a:r>
           </a:p>
         </p:txBody>
@@ -8937,7 +8937,7 @@
                 </a:solidFill>
                 <a:latin typeface="Segoe UI"/>
               </a:rPr>
-              <a:t>Khởi chạy song song 2 instance backend (api1:3000, api2:3000) trong compose.yaml. Gửi liên tiếp 10 request 'GET /api/products'.</a:t>
+              <a:t>Khởi chạy song song 2 instance backend (api1:3000, api2:3000) trong compose.yaml. Gửi liên tiếp 10 request 'GET /api/products' hoặc tạo đơn hàng.</a:t>
             </a:r>
           </a:p>
           <a:p>
@@ -8962,7 +8962,7 @@
                 </a:solidFill>
                 <a:latin typeface="Segoe UI"/>
               </a:rPr>
-              <a:t>Dữ liệu phản hồi mang trường 'instanceId' luân phiên giữa api1 và api2, chứng minh tải được phân phối đều giữa 2 node.</a:t>
+              <a:t>Dữ liệu phản hồi mang header X-Backend-Instance và trường 'instanceId' luân phiên giữa api1 và api2, chứng minh tải được phân phối đều.</a:t>
             </a:r>
           </a:p>
           <a:p>
@@ -9231,7 +9231,7 @@
               </a:defRPr>
             </a:pPr>
             <a:r>
-              <a:t>Nhóm 7 • NGINX Reverse Proxy &amp; Upstream nhiều Backend</a:t>
+              <a:t>Nhóm 8 • NGINX Reverse Proxy &amp; Upstream nhiều Backend</a:t>
             </a:r>
           </a:p>
         </p:txBody>
@@ -9946,7 +9946,7 @@
               </a:defRPr>
             </a:pPr>
             <a:r>
-              <a:t>Nhóm 7 • NGINX Reverse Proxy &amp; Upstream nhiều Backend</a:t>
+              <a:t>Nhóm 8 • NGINX Reverse Proxy &amp; Upstream nhiều Backend</a:t>
             </a:r>
           </a:p>
         </p:txBody>
@@ -10919,7 +10919,7 @@
               </a:defRPr>
             </a:pPr>
             <a:r>
-              <a:t>Nhóm 7 • NGINX Reverse Proxy &amp; Upstream nhiều Backend</a:t>
+              <a:t>Nhóm 8 • NGINX Reverse Proxy &amp; Upstream nhiều Backend</a:t>
             </a:r>
           </a:p>
         </p:txBody>
@@ -11527,7 +11527,7 @@
                 </a:solidFill>
                 <a:latin typeface="Segoe UI"/>
               </a:rPr>
-              <a:t>Gửi payload 2 MB tới endpoint 'POST /api/upload' khi NGINX ở cấu hình mặc định (1m). Quan sát lỗi 413. Sửa 'client_max_body_size 20m;', chạy 'nginx -t', reload và gửi lại.</a:t>
+              <a:t>Gửi ảnh bìa 1.34 MB tới 'POST /api/products/1/image' khi NGINX ở cấu hình mặc định (1m). Quan sát lỗi 413. Nâng 'client_max_body_size 20m;', chạy 'nginx -t', reload và gửi lại.</a:t>
             </a:r>
           </a:p>
           <a:p>
@@ -11552,7 +11552,7 @@
                 </a:solidFill>
                 <a:latin typeface="Segoe UI"/>
               </a:rPr>
-              <a:t>Lần 1 nhận chính xác HTTP 413 Payload Too Large. Lần 2 sau khi reload cấu hình nóng, upload thành công nhận mã HTTP 200 OK.</a:t>
+              <a:t>Lần 1 nhận chính xác HTTP 413 Payload Too Large. Lần 2 sau khi reload cấu hình nóng, upload thành công nhận mã HTTP 200 OK và ảnh lưu vào uploads_data.</a:t>
             </a:r>
           </a:p>
           <a:p>
@@ -11821,7 +11821,7 @@
               </a:defRPr>
             </a:pPr>
             <a:r>
-              <a:t>Nhóm 7 • NGINX Reverse Proxy &amp; Upstream nhiều Backend</a:t>
+              <a:t>Nhóm 8 • NGINX Reverse Proxy &amp; Upstream nhiều Backend</a:t>
             </a:r>
           </a:p>
         </p:txBody>
@@ -12692,7 +12692,7 @@
               </a:defRPr>
             </a:pPr>
             <a:r>
-              <a:t>Nhóm 7 • NGINX Reverse Proxy &amp; Upstream nhiều Backend</a:t>
+              <a:t>Nhóm 8 • NGINX Reverse Proxy &amp; Upstream nhiều Backend</a:t>
             </a:r>
           </a:p>
         </p:txBody>
@@ -13708,7 +13708,7 @@
               </a:defRPr>
             </a:pPr>
             <a:r>
-              <a:t>Nhóm 7 • NGINX Reverse Proxy &amp; Upstream nhiều Backend</a:t>
+              <a:t>Nhóm 8 • NGINX Reverse Proxy &amp; Upstream nhiều Backend</a:t>
             </a:r>
           </a:p>
         </p:txBody>
@@ -14644,7 +14644,7 @@
               </a:defRPr>
             </a:pPr>
             <a:r>
-              <a:t>Nhóm 7 • NGINX Reverse Proxy &amp; Upstream nhiều Backend</a:t>
+              <a:t>Nhóm 8 • NGINX Reverse Proxy &amp; Upstream nhiều Backend</a:t>
             </a:r>
           </a:p>
         </p:txBody>
@@ -15515,7 +15515,7 @@
               </a:defRPr>
             </a:pPr>
             <a:r>
-              <a:t>Nhóm 7 • NGINX Reverse Proxy &amp; Upstream nhiều Backend</a:t>
+              <a:t>Nhóm 8 • NGINX Reverse Proxy &amp; Upstream nhiều Backend</a:t>
             </a:r>
           </a:p>
         </p:txBody>
@@ -15753,7 +15753,7 @@
                   <a:srgbClr val="0F172A"/>
                 </a:solidFill>
               </a:rPr>
-              <a:t>Slide Nhóm 6 là tài liệu tham chiếu kiến trúc, không phải bằng chứng Nhóm 7 đang sở hữu một ứng dụng chạy sẵn từ trước.</a:t>
+              <a:t>Slide Nhóm 6 là tài liệu tham chiếu kiến trúc, không phải bằng chứng Nhóm 8 đang sở hữu một ứng dụng chạy sẵn từ trước.</a:t>
             </a:r>
           </a:p>
           <a:p>
@@ -15895,7 +15895,7 @@
                   <a:srgbClr val="16A34A"/>
                 </a:solidFill>
               </a:rPr>
-              <a:t>✔ Ứng dụng Quản lý Sản phẩm Mini: </a:t>
+              <a:t>✔ HUCE Learning Store (Sách &amp; Khóa học): </a:t>
             </a:r>
             <a:r>
               <a:rPr sz="1450">
@@ -15903,7 +15903,7 @@
                   <a:srgbClr val="0F172A"/>
                 </a:solidFill>
               </a:rPr>
-              <a:t>Xây dựng dự án chạy thật: Frontend tĩnh (SPA), 2 backend Node.js (api1 &amp; api2 cổng 3000), CSDL PostgreSQL (db:5432), shared volume uploads và NGINX Gateway (8080:80, 8443:443).</a:t>
+              <a:t>Xây dựng dự án chạy thật: Frontend tĩnh (SPA), 2 backend Node.js (api1 &amp; api2 cổng 3000), CSDL PostgreSQL (db:5432) lưu sách, khóa học và đơn hàng thật, shared volume uploads và NGINX Gateway (8080:80, 8443:443).</a:t>
             </a:r>
           </a:p>
           <a:p>
@@ -16198,7 +16198,7 @@
               </a:defRPr>
             </a:pPr>
             <a:r>
-              <a:t>Nhóm 7 • NGINX Reverse Proxy &amp; Upstream nhiều Backend</a:t>
+              <a:t>Nhóm 8 • NGINX Reverse Proxy &amp; Upstream nhiều Backend</a:t>
             </a:r>
           </a:p>
         </p:txBody>
@@ -16925,7 +16925,7 @@
               </a:defRPr>
             </a:pPr>
             <a:r>
-              <a:t>Nhóm 7 xin trân trọng cảm ơn Thầy và các bạn đã chú ý lắng nghe bài báo cáo!</a:t>
+              <a:t>Nhóm 8 xin trân trọng cảm ơn Thầy và các bạn đã chú ý lắng nghe bài báo cáo!</a:t>
             </a:r>
           </a:p>
         </p:txBody>
@@ -17174,7 +17174,7 @@
               </a:defRPr>
             </a:pPr>
             <a:r>
-              <a:t>Nhóm 7 • NGINX Reverse Proxy &amp; Upstream nhiều Backend</a:t>
+              <a:t>Nhóm 8 • NGINX Reverse Proxy &amp; Upstream nhiều Backend</a:t>
             </a:r>
           </a:p>
         </p:txBody>
@@ -17857,7 +17857,7 @@
               </a:defRPr>
             </a:pPr>
             <a:r>
-              <a:t>Nhóm 7 • NGINX Reverse Proxy &amp; Upstream nhiều Backend</a:t>
+              <a:t>Nhóm 8 • NGINX Reverse Proxy &amp; Upstream nhiều Backend</a:t>
             </a:r>
           </a:p>
         </p:txBody>
@@ -18725,7 +18725,7 @@
               </a:defRPr>
             </a:pPr>
             <a:r>
-              <a:t>Nhóm 7 • NGINX Reverse Proxy &amp; Upstream nhiều Backend</a:t>
+              <a:t>Nhóm 8 • NGINX Reverse Proxy &amp; Upstream nhiều Backend</a:t>
             </a:r>
           </a:p>
         </p:txBody>
@@ -19416,7 +19416,7 @@
               </a:defRPr>
             </a:pPr>
             <a:r>
-              <a:t>Nhóm 7 • NGINX Reverse Proxy &amp; Upstream nhiều Backend</a:t>
+              <a:t>Nhóm 8 • NGINX Reverse Proxy &amp; Upstream nhiều Backend</a:t>
             </a:r>
           </a:p>
         </p:txBody>
@@ -20007,7 +20007,7 @@
             </a:r>
             <a:br/>
             <a:r>
-              <a:t>(GET /api/products)</a:t>
+              <a:t>(GET /api/products, POST /api/orders)</a:t>
             </a:r>
           </a:p>
         </p:txBody>
@@ -20088,7 +20088,7 @@
               </a:defRPr>
             </a:pPr>
             <a:r>
-              <a:t>Ví dụ URL thực tế: Người dùng mở 'http://myapp.local:8080/' -&gt; NGINX trả giao diện index.html. JavaScript gọi ngầm 'http://myapp.local:8080/api/products' -&gt; NGINX chuyển tiếp tới 'http://backend_cluster/api/products' tại cổng nội bộ 3000.</a:t>
+              <a:t>Ví dụ URL thực tế: Người dùng mở 'http://myapp.local:8080/' -&gt; NGINX trả giao diện HUCE Learning Store. JavaScript gọi ngầm 'http://myapp.local:8080/api/products' hoặc tạo đơn hàng -&gt; NGINX chuyển tiếp tới 'http://backend_cluster/api/...' tại cổng nội bộ 3000.</a:t>
             </a:r>
           </a:p>
         </p:txBody>
@@ -20337,7 +20337,7 @@
               </a:defRPr>
             </a:pPr>
             <a:r>
-              <a:t>Nhóm 7 • NGINX Reverse Proxy &amp; Upstream nhiều Backend</a:t>
+              <a:t>Nhóm 8 • NGINX Reverse Proxy &amp; Upstream nhiều Backend</a:t>
             </a:r>
           </a:p>
         </p:txBody>
@@ -21076,7 +21076,7 @@
               </a:defRPr>
             </a:pPr>
             <a:r>
-              <a:t>Nhóm 7 • NGINX Reverse Proxy &amp; Upstream nhiều Backend</a:t>
+              <a:t>Nhóm 8 • NGINX Reverse Proxy &amp; Upstream nhiều Backend</a:t>
             </a:r>
           </a:p>
         </p:txBody>
@@ -22095,7 +22095,7 @@
               </a:defRPr>
             </a:pPr>
             <a:r>
-              <a:t>Nhóm 7 • NGINX Reverse Proxy &amp; Upstream nhiều Backend</a:t>
+              <a:t>Nhóm 8 • NGINX Reverse Proxy &amp; Upstream nhiều Backend</a:t>
             </a:r>
           </a:p>
         </p:txBody>

</xml_diff>